<commit_message>
Add new solution script for Programming-1 lab exercises
</commit_message>
<xml_diff>
--- a/SEM-1/IKS/India_with_WWI_nationalism 2.pptx
+++ b/SEM-1/IKS/India_with_WWI_nationalism 2.pptx
@@ -1994,7 +1994,7 @@
           <a:p>
             <a:fld id="{C764DE79-268F-4C1A-8933-263129D2AF90}" type="datetimeFigureOut">
               <a:rPr lang="en-US" smtClean="0"/>
-              <a:t>8/4/26</a:t>
+              <a:t>10/12/26</a:t>
             </a:fld>
             <a:endParaRPr lang="en-US" dirty="0"/>
           </a:p>
@@ -2206,7 +2206,7 @@
           <a:p>
             <a:fld id="{C764DE79-268F-4C1A-8933-263129D2AF90}" type="datetimeFigureOut">
               <a:rPr lang="en-US" smtClean="0"/>
-              <a:t>8/4/26</a:t>
+              <a:t>10/12/26</a:t>
             </a:fld>
             <a:endParaRPr lang="en-US" dirty="0"/>
           </a:p>
@@ -2422,7 +2422,7 @@
           <a:p>
             <a:fld id="{C764DE79-268F-4C1A-8933-263129D2AF90}" type="datetimeFigureOut">
               <a:rPr lang="en-US" smtClean="0"/>
-              <a:t>8/4/26</a:t>
+              <a:t>10/12/26</a:t>
             </a:fld>
             <a:endParaRPr lang="en-US" dirty="0"/>
           </a:p>
@@ -2659,7 +2659,7 @@
           <a:p>
             <a:fld id="{C764DE79-268F-4C1A-8933-263129D2AF90}" type="datetimeFigureOut">
               <a:rPr lang="en-US" smtClean="0"/>
-              <a:t>8/4/26</a:t>
+              <a:t>10/12/26</a:t>
             </a:fld>
             <a:endParaRPr lang="en-US" dirty="0"/>
           </a:p>
@@ -2939,7 +2939,7 @@
           <a:p>
             <a:fld id="{C764DE79-268F-4C1A-8933-263129D2AF90}" type="datetimeFigureOut">
               <a:rPr lang="en-US" smtClean="0"/>
-              <a:t>8/4/26</a:t>
+              <a:t>10/12/26</a:t>
             </a:fld>
             <a:endParaRPr lang="en-US" dirty="0"/>
           </a:p>
@@ -3208,7 +3208,7 @@
           <a:p>
             <a:fld id="{C764DE79-268F-4C1A-8933-263129D2AF90}" type="datetimeFigureOut">
               <a:rPr lang="en-US" smtClean="0"/>
-              <a:t>8/4/26</a:t>
+              <a:t>10/12/26</a:t>
             </a:fld>
             <a:endParaRPr lang="en-US" dirty="0"/>
           </a:p>
@@ -3625,7 +3625,7 @@
           <a:p>
             <a:fld id="{C764DE79-268F-4C1A-8933-263129D2AF90}" type="datetimeFigureOut">
               <a:rPr lang="en-US" smtClean="0"/>
-              <a:t>8/4/26</a:t>
+              <a:t>10/12/26</a:t>
             </a:fld>
             <a:endParaRPr lang="en-US" dirty="0"/>
           </a:p>
@@ -3775,7 +3775,7 @@
           <a:p>
             <a:fld id="{C764DE79-268F-4C1A-8933-263129D2AF90}" type="datetimeFigureOut">
               <a:rPr lang="en-US" smtClean="0"/>
-              <a:t>8/4/26</a:t>
+              <a:t>10/12/26</a:t>
             </a:fld>
             <a:endParaRPr lang="en-US" dirty="0"/>
           </a:p>
@@ -3902,7 +3902,7 @@
           <a:p>
             <a:fld id="{C764DE79-268F-4C1A-8933-263129D2AF90}" type="datetimeFigureOut">
               <a:rPr lang="en-US" smtClean="0"/>
-              <a:t>8/4/26</a:t>
+              <a:t>10/12/26</a:t>
             </a:fld>
             <a:endParaRPr lang="en-US" dirty="0"/>
           </a:p>
@@ -4154,7 +4154,7 @@
           <a:p>
             <a:fld id="{C764DE79-268F-4C1A-8933-263129D2AF90}" type="datetimeFigureOut">
               <a:rPr lang="en-US" smtClean="0"/>
-              <a:t>8/4/26</a:t>
+              <a:t>10/12/26</a:t>
             </a:fld>
             <a:endParaRPr lang="en-US" dirty="0"/>
           </a:p>
@@ -4600,7 +4600,7 @@
           <a:p>
             <a:fld id="{C764DE79-268F-4C1A-8933-263129D2AF90}" type="datetimeFigureOut">
               <a:rPr lang="en-US" smtClean="0"/>
-              <a:t>8/4/26</a:t>
+              <a:t>10/12/26</a:t>
             </a:fld>
             <a:endParaRPr lang="en-US" dirty="0"/>
           </a:p>
@@ -4935,7 +4935,7 @@
           <a:p>
             <a:fld id="{C764DE79-268F-4C1A-8933-263129D2AF90}" type="datetimeFigureOut">
               <a:rPr lang="en-US" smtClean="0"/>
-              <a:t>8/4/26</a:t>
+              <a:t>10/12/26</a:t>
             </a:fld>
             <a:endParaRPr lang="en-US" dirty="0"/>
           </a:p>
@@ -8407,7 +8407,7 @@
         </p:blipFill>
         <p:spPr>
           <a:xfrm>
-            <a:off x="0" y="0"/>
+            <a:off x="-73419" y="0"/>
             <a:ext cx="9144000" cy="5143500"/>
           </a:xfrm>
           <a:prstGeom prst="rect">

</xml_diff>